<commit_message>
Update 몸으로 말해요 assets and add ZIP slides
Co-Authored-By: Claude Opus 4.6 (1M context) <noreply@anthropic.com>
</commit_message>
<xml_diff>
--- a/public/downloads/games/body-talk/rules.pptx
+++ b/public/downloads/games/body-talk/rules.pptx
@@ -43,16 +43,12 @@
   <p:notesSz cx="6858000" cy="9144000"/>
   <p:embeddedFontLst>
     <p:embeddedFont>
-      <p:font typeface="Jua" charset="1" panose="00000000000000000000"/>
+      <p:font typeface="무궁화 고딕" charset="1" panose="02020603020101020101"/>
       <p:regular r:id="rId39"/>
     </p:embeddedFont>
     <p:embeddedFont>
-      <p:font typeface="TDTD갬성명조" charset="1" panose="02000503000000000000"/>
+      <p:font typeface="무궁화 고딕 Bold" charset="1" panose="02020603020101020101"/>
       <p:regular r:id="rId40"/>
-    </p:embeddedFont>
-    <p:embeddedFont>
-      <p:font typeface="TDTD가온" charset="1" panose="02000503000000000000"/>
-      <p:regular r:id="rId41"/>
     </p:embeddedFont>
   </p:embeddedFontLst>
   <p:defaultTextStyle>
@@ -3170,8 +3166,8 @@
         </p:nvSpPr>
         <p:spPr>
           <a:xfrm rot="0">
-            <a:off x="1028700" y="3892867"/>
-            <a:ext cx="15555091" cy="2200275"/>
+            <a:off x="1028700" y="4178617"/>
+            <a:ext cx="15555091" cy="1914525"/>
           </a:xfrm>
           <a:prstGeom prst="rect">
             <a:avLst/>
@@ -3193,10 +3189,10 @@
                 <a:solidFill>
                   <a:srgbClr val="FFFAEF"/>
                 </a:solidFill>
-                <a:latin typeface="Jua"/>
-                <a:ea typeface="Jua"/>
-                <a:cs typeface="Jua"/>
-                <a:sym typeface="Jua"/>
+                <a:latin typeface="무궁화 고딕"/>
+                <a:ea typeface="무궁화 고딕"/>
+                <a:cs typeface="무궁화 고딕"/>
+                <a:sym typeface="무궁화 고딕"/>
               </a:rPr>
               <a:t>몸으로 말해요</a:t>
             </a:r>
@@ -3211,8 +3207,8 @@
         </p:nvSpPr>
         <p:spPr>
           <a:xfrm rot="0">
-            <a:off x="15264803" y="9812655"/>
-            <a:ext cx="2637975" cy="474345"/>
+            <a:off x="13460066" y="9822180"/>
+            <a:ext cx="4442712" cy="464820"/>
           </a:xfrm>
           <a:prstGeom prst="rect">
             <a:avLst/>
@@ -3237,10 +3233,10 @@
                 <a:solidFill>
                   <a:srgbClr val="FFFFFF"/>
                 </a:solidFill>
-                <a:latin typeface="TDTD갬성명조"/>
-                <a:ea typeface="TDTD갬성명조"/>
-                <a:cs typeface="TDTD갬성명조"/>
-                <a:sym typeface="TDTD갬성명조"/>
+                <a:latin typeface="무궁화 고딕"/>
+                <a:ea typeface="무궁화 고딕"/>
+                <a:cs typeface="무궁화 고딕"/>
+                <a:sym typeface="무궁화 고딕"/>
               </a:rPr>
               <a:t>ⓒ 2026. Sunday Play</a:t>
             </a:r>
@@ -3287,8 +3283,8 @@
         </p:nvSpPr>
         <p:spPr>
           <a:xfrm rot="0">
-            <a:off x="3238925" y="4092795"/>
-            <a:ext cx="11810151" cy="2200275"/>
+            <a:off x="3238925" y="4378545"/>
+            <a:ext cx="11810151" cy="1914525"/>
           </a:xfrm>
           <a:prstGeom prst="rect">
             <a:avLst/>
@@ -3310,10 +3306,10 @@
                 <a:solidFill>
                   <a:srgbClr val="000000"/>
                 </a:solidFill>
-                <a:latin typeface="Jua"/>
-                <a:ea typeface="Jua"/>
-                <a:cs typeface="Jua"/>
-                <a:sym typeface="Jua"/>
+                <a:latin typeface="무궁화 고딕"/>
+                <a:ea typeface="무궁화 고딕"/>
+                <a:cs typeface="무궁화 고딕"/>
+                <a:sym typeface="무궁화 고딕"/>
               </a:rPr>
               <a:t>가위바위보</a:t>
             </a:r>
@@ -3410,8 +3406,8 @@
         </p:nvSpPr>
         <p:spPr>
           <a:xfrm rot="0">
-            <a:off x="3238925" y="4092795"/>
-            <a:ext cx="11810151" cy="2200275"/>
+            <a:off x="3238925" y="4378545"/>
+            <a:ext cx="11810151" cy="1914525"/>
           </a:xfrm>
           <a:prstGeom prst="rect">
             <a:avLst/>
@@ -3433,10 +3429,10 @@
                 <a:solidFill>
                   <a:srgbClr val="000000"/>
                 </a:solidFill>
-                <a:latin typeface="Jua"/>
-                <a:ea typeface="Jua"/>
-                <a:cs typeface="Jua"/>
-                <a:sym typeface="Jua"/>
+                <a:latin typeface="무궁화 고딕"/>
+                <a:ea typeface="무궁화 고딕"/>
+                <a:cs typeface="무궁화 고딕"/>
+                <a:sym typeface="무궁화 고딕"/>
               </a:rPr>
               <a:t>줄넘기</a:t>
             </a:r>
@@ -3533,8 +3529,8 @@
         </p:nvSpPr>
         <p:spPr>
           <a:xfrm rot="0">
-            <a:off x="3238925" y="4092795"/>
-            <a:ext cx="11810151" cy="2200275"/>
+            <a:off x="3238925" y="4378545"/>
+            <a:ext cx="11810151" cy="1914525"/>
           </a:xfrm>
           <a:prstGeom prst="rect">
             <a:avLst/>
@@ -3556,10 +3552,10 @@
                 <a:solidFill>
                   <a:srgbClr val="000000"/>
                 </a:solidFill>
-                <a:latin typeface="Jua"/>
-                <a:ea typeface="Jua"/>
-                <a:cs typeface="Jua"/>
-                <a:sym typeface="Jua"/>
+                <a:latin typeface="무궁화 고딕"/>
+                <a:ea typeface="무궁화 고딕"/>
+                <a:cs typeface="무궁화 고딕"/>
+                <a:sym typeface="무궁화 고딕"/>
               </a:rPr>
               <a:t>롤러코스터</a:t>
             </a:r>
@@ -3656,8 +3652,8 @@
         </p:nvSpPr>
         <p:spPr>
           <a:xfrm rot="0">
-            <a:off x="2133812" y="3895725"/>
-            <a:ext cx="14020375" cy="2200275"/>
+            <a:off x="2133812" y="4243387"/>
+            <a:ext cx="14020375" cy="1790700"/>
           </a:xfrm>
           <a:prstGeom prst="rect">
             <a:avLst/>
@@ -3671,18 +3667,18 @@
           <a:p>
             <a:pPr algn="ctr">
               <a:lnSpc>
-                <a:spcPts val="15000"/>
+                <a:spcPts val="14040"/>
               </a:lnSpc>
             </a:pPr>
             <a:r>
-              <a:rPr lang="en-US" sz="12500">
+              <a:rPr lang="en-US" sz="11700">
                 <a:solidFill>
                   <a:srgbClr val="000000"/>
                 </a:solidFill>
-                <a:latin typeface="Jua"/>
-                <a:ea typeface="Jua"/>
-                <a:cs typeface="Jua"/>
-                <a:sym typeface="Jua"/>
+                <a:latin typeface="무궁화 고딕"/>
+                <a:ea typeface="무궁화 고딕"/>
+                <a:cs typeface="무궁화 고딕"/>
+                <a:sym typeface="무궁화 고딕"/>
               </a:rPr>
               <a:t>고르곤졸라 먹는 조인성</a:t>
             </a:r>
@@ -3779,8 +3775,8 @@
         </p:nvSpPr>
         <p:spPr>
           <a:xfrm rot="0">
-            <a:off x="3238925" y="4092795"/>
-            <a:ext cx="11810151" cy="2200275"/>
+            <a:off x="3238925" y="4416645"/>
+            <a:ext cx="11810151" cy="1838325"/>
           </a:xfrm>
           <a:prstGeom prst="rect">
             <a:avLst/>
@@ -3794,18 +3790,18 @@
           <a:p>
             <a:pPr algn="ctr">
               <a:lnSpc>
-                <a:spcPts val="15000"/>
+                <a:spcPts val="14400"/>
               </a:lnSpc>
             </a:pPr>
             <a:r>
-              <a:rPr lang="en-US" sz="12500">
+              <a:rPr lang="en-US" sz="12000">
                 <a:solidFill>
                   <a:srgbClr val="000000"/>
                 </a:solidFill>
-                <a:latin typeface="Jua"/>
-                <a:ea typeface="Jua"/>
-                <a:cs typeface="Jua"/>
-                <a:sym typeface="Jua"/>
+                <a:latin typeface="무궁화 고딕"/>
+                <a:ea typeface="무궁화 고딕"/>
+                <a:cs typeface="무궁화 고딕"/>
+                <a:sym typeface="무궁화 고딕"/>
               </a:rPr>
               <a:t>미끄럼틀 타는 공룡</a:t>
             </a:r>
@@ -3902,8 +3898,8 @@
         </p:nvSpPr>
         <p:spPr>
           <a:xfrm rot="0">
-            <a:off x="3238925" y="4092795"/>
-            <a:ext cx="11810151" cy="2200275"/>
+            <a:off x="3238925" y="4378545"/>
+            <a:ext cx="11810151" cy="1914525"/>
           </a:xfrm>
           <a:prstGeom prst="rect">
             <a:avLst/>
@@ -3925,10 +3921,10 @@
                 <a:solidFill>
                   <a:srgbClr val="000000"/>
                 </a:solidFill>
-                <a:latin typeface="Jua"/>
-                <a:ea typeface="Jua"/>
-                <a:cs typeface="Jua"/>
-                <a:sym typeface="Jua"/>
+                <a:latin typeface="무궁화 고딕"/>
+                <a:ea typeface="무궁화 고딕"/>
+                <a:cs typeface="무궁화 고딕"/>
+                <a:sym typeface="무궁화 고딕"/>
               </a:rPr>
               <a:t>방귀</a:t>
             </a:r>
@@ -4025,8 +4021,8 @@
         </p:nvSpPr>
         <p:spPr>
           <a:xfrm rot="0">
-            <a:off x="3238925" y="4092795"/>
-            <a:ext cx="11810151" cy="2200275"/>
+            <a:off x="3238925" y="4378545"/>
+            <a:ext cx="11810151" cy="1914525"/>
           </a:xfrm>
           <a:prstGeom prst="rect">
             <a:avLst/>
@@ -4048,10 +4044,10 @@
                 <a:solidFill>
                   <a:srgbClr val="000000"/>
                 </a:solidFill>
-                <a:latin typeface="Jua"/>
-                <a:ea typeface="Jua"/>
-                <a:cs typeface="Jua"/>
-                <a:sym typeface="Jua"/>
+                <a:latin typeface="무궁화 고딕"/>
+                <a:ea typeface="무궁화 고딕"/>
+                <a:cs typeface="무궁화 고딕"/>
+                <a:sym typeface="무궁화 고딕"/>
               </a:rPr>
               <a:t>거울 보며 윙크</a:t>
             </a:r>
@@ -4148,8 +4144,8 @@
         </p:nvSpPr>
         <p:spPr>
           <a:xfrm rot="0">
-            <a:off x="3238925" y="4092795"/>
-            <a:ext cx="11810151" cy="2200275"/>
+            <a:off x="3238925" y="4378545"/>
+            <a:ext cx="11810151" cy="1914525"/>
           </a:xfrm>
           <a:prstGeom prst="rect">
             <a:avLst/>
@@ -4171,10 +4167,10 @@
                 <a:solidFill>
                   <a:srgbClr val="000000"/>
                 </a:solidFill>
-                <a:latin typeface="Jua"/>
-                <a:ea typeface="Jua"/>
-                <a:cs typeface="Jua"/>
-                <a:sym typeface="Jua"/>
+                <a:latin typeface="무궁화 고딕"/>
+                <a:ea typeface="무궁화 고딕"/>
+                <a:cs typeface="무궁화 고딕"/>
+                <a:sym typeface="무궁화 고딕"/>
               </a:rPr>
               <a:t>트림하는 선생님</a:t>
             </a:r>
@@ -4271,8 +4267,8 @@
         </p:nvSpPr>
         <p:spPr>
           <a:xfrm rot="0">
-            <a:off x="3238925" y="4092795"/>
-            <a:ext cx="11810151" cy="2200275"/>
+            <a:off x="3238925" y="4378545"/>
+            <a:ext cx="11810151" cy="1914525"/>
           </a:xfrm>
           <a:prstGeom prst="rect">
             <a:avLst/>
@@ -4294,10 +4290,10 @@
                 <a:solidFill>
                   <a:srgbClr val="000000"/>
                 </a:solidFill>
-                <a:latin typeface="Jua"/>
-                <a:ea typeface="Jua"/>
-                <a:cs typeface="Jua"/>
-                <a:sym typeface="Jua"/>
+                <a:latin typeface="무궁화 고딕"/>
+                <a:ea typeface="무궁화 고딕"/>
+                <a:cs typeface="무궁화 고딕"/>
+                <a:sym typeface="무궁화 고딕"/>
               </a:rPr>
               <a:t>라면</a:t>
             </a:r>
@@ -4394,8 +4390,8 @@
         </p:nvSpPr>
         <p:spPr>
           <a:xfrm rot="0">
-            <a:off x="3238925" y="4092795"/>
-            <a:ext cx="11810151" cy="2200275"/>
+            <a:off x="3238925" y="4378545"/>
+            <a:ext cx="11810151" cy="1914525"/>
           </a:xfrm>
           <a:prstGeom prst="rect">
             <a:avLst/>
@@ -4417,10 +4413,10 @@
                 <a:solidFill>
                   <a:srgbClr val="000000"/>
                 </a:solidFill>
-                <a:latin typeface="Jua"/>
-                <a:ea typeface="Jua"/>
-                <a:cs typeface="Jua"/>
-                <a:sym typeface="Jua"/>
+                <a:latin typeface="무궁화 고딕"/>
+                <a:ea typeface="무궁화 고딕"/>
+                <a:cs typeface="무궁화 고딕"/>
+                <a:sym typeface="무궁화 고딕"/>
               </a:rPr>
               <a:t>권투하는 할머니</a:t>
             </a:r>
@@ -4619,8 +4615,8 @@
         </p:nvSpPr>
         <p:spPr>
           <a:xfrm rot="0">
-            <a:off x="11392761" y="600705"/>
-            <a:ext cx="5362043" cy="1600200"/>
+            <a:off x="11392761" y="819780"/>
+            <a:ext cx="5362043" cy="1381125"/>
           </a:xfrm>
           <a:prstGeom prst="rect">
             <a:avLst/>
@@ -4642,10 +4638,10 @@
                 <a:solidFill>
                   <a:srgbClr val="FFFAEF"/>
                 </a:solidFill>
-                <a:latin typeface="Jua"/>
-                <a:ea typeface="Jua"/>
-                <a:cs typeface="Jua"/>
-                <a:sym typeface="Jua"/>
+                <a:latin typeface="무궁화 고딕"/>
+                <a:ea typeface="무궁화 고딕"/>
+                <a:cs typeface="무궁화 고딕"/>
+                <a:sym typeface="무궁화 고딕"/>
               </a:rPr>
               <a:t>규칙</a:t>
             </a:r>
@@ -4661,9 +4657,9 @@
         <p:grpSpPr>
           <a:xfrm rot="0">
             <a:off x="309172" y="535073"/>
-            <a:ext cx="10694683" cy="2573620"/>
+            <a:ext cx="10694683" cy="2406534"/>
             <a:chOff x="0" y="0"/>
-            <a:chExt cx="14259577" cy="3431493"/>
+            <a:chExt cx="14259577" cy="3208711"/>
           </a:xfrm>
         </p:grpSpPr>
         <p:sp>
@@ -4674,8 +4670,8 @@
           </p:nvSpPr>
           <p:spPr>
             <a:xfrm rot="0">
-              <a:off x="0" y="1380584"/>
-              <a:ext cx="14259577" cy="2050910"/>
+              <a:off x="0" y="1388378"/>
+              <a:ext cx="14259577" cy="1820333"/>
             </a:xfrm>
             <a:prstGeom prst="rect">
               <a:avLst/>
@@ -4689,18 +4685,18 @@
             <a:p>
               <a:pPr algn="l">
                 <a:lnSpc>
-                  <a:spcPts val="6273"/>
+                  <a:spcPts val="5599"/>
                 </a:lnSpc>
               </a:pPr>
               <a:r>
-                <a:rPr lang="en-US" sz="4480">
+                <a:rPr lang="en-US" sz="3999">
                   <a:solidFill>
                     <a:srgbClr val="FFFAEF"/>
                   </a:solidFill>
-                  <a:latin typeface="TDTD가온"/>
-                  <a:ea typeface="TDTD가온"/>
-                  <a:cs typeface="TDTD가온"/>
-                  <a:sym typeface="TDTD가온"/>
+                  <a:latin typeface="무궁화 고딕"/>
+                  <a:ea typeface="무궁화 고딕"/>
+                  <a:cs typeface="무궁화 고딕"/>
+                  <a:sym typeface="무궁화 고딕"/>
                 </a:rPr>
                 <a:t>팀별 도전 순서를 정합니다.</a:t>
               </a:r>
@@ -4708,18 +4704,18 @@
             <a:p>
               <a:pPr algn="l">
                 <a:lnSpc>
-                  <a:spcPts val="6273"/>
+                  <a:spcPts val="5599"/>
                 </a:lnSpc>
               </a:pPr>
               <a:r>
-                <a:rPr lang="en-US" sz="4480">
+                <a:rPr lang="en-US" sz="3999">
                   <a:solidFill>
                     <a:srgbClr val="FFFAEF"/>
                   </a:solidFill>
-                  <a:latin typeface="TDTD가온"/>
-                  <a:ea typeface="TDTD가온"/>
-                  <a:cs typeface="TDTD가온"/>
-                  <a:sym typeface="TDTD가온"/>
+                  <a:latin typeface="무궁화 고딕"/>
+                  <a:ea typeface="무궁화 고딕"/>
+                  <a:cs typeface="무궁화 고딕"/>
+                  <a:sym typeface="무궁화 고딕"/>
                 </a:rPr>
                 <a:t>팀 대표가 앞에 나와 제시어를 확인합니다.</a:t>
               </a:r>
@@ -4734,8 +4730,8 @@
           </p:nvSpPr>
           <p:spPr>
             <a:xfrm rot="0">
-              <a:off x="0" y="-171450"/>
-              <a:ext cx="9574913" cy="1169217"/>
+              <a:off x="0" y="-66675"/>
+              <a:ext cx="9574913" cy="1062712"/>
             </a:xfrm>
             <a:prstGeom prst="rect">
               <a:avLst/>
@@ -4757,10 +4753,10 @@
                   <a:solidFill>
                     <a:srgbClr val="FFFAEF"/>
                   </a:solidFill>
-                  <a:latin typeface="Jua"/>
-                  <a:ea typeface="Jua"/>
-                  <a:cs typeface="Jua"/>
-                  <a:sym typeface="Jua"/>
+                  <a:latin typeface="무궁화 고딕 Bold"/>
+                  <a:ea typeface="무궁화 고딕 Bold"/>
+                  <a:cs typeface="무궁화 고딕 Bold"/>
+                  <a:sym typeface="무궁화 고딕 Bold"/>
                 </a:rPr>
                 <a:t>STEP 1.</a:t>
               </a:r>
@@ -4777,9 +4773,9 @@
         <p:grpSpPr>
           <a:xfrm rot="0">
             <a:off x="9649747" y="8200435"/>
-            <a:ext cx="8487123" cy="1778769"/>
+            <a:ext cx="8487123" cy="1681352"/>
             <a:chOff x="0" y="0"/>
-            <a:chExt cx="11316164" cy="2371692"/>
+            <a:chExt cx="11316164" cy="2241803"/>
           </a:xfrm>
         </p:grpSpPr>
         <p:sp>
@@ -4790,8 +4786,8 @@
           </p:nvSpPr>
           <p:spPr>
             <a:xfrm rot="0">
-              <a:off x="0" y="1377534"/>
-              <a:ext cx="11143161" cy="994158"/>
+              <a:off x="0" y="1373758"/>
+              <a:ext cx="11143161" cy="868045"/>
             </a:xfrm>
             <a:prstGeom prst="rect">
               <a:avLst/>
@@ -4805,18 +4801,18 @@
             <a:p>
               <a:pPr algn="l">
                 <a:lnSpc>
-                  <a:spcPts val="6284"/>
+                  <a:spcPts val="5460"/>
                 </a:lnSpc>
               </a:pPr>
               <a:r>
-                <a:rPr lang="en-US" sz="4489">
+                <a:rPr lang="en-US" sz="3900">
                   <a:solidFill>
                     <a:srgbClr val="FFFAEF"/>
                   </a:solidFill>
-                  <a:latin typeface="TDTD가온"/>
-                  <a:ea typeface="TDTD가온"/>
-                  <a:cs typeface="TDTD가온"/>
-                  <a:sym typeface="TDTD가온"/>
+                  <a:latin typeface="무궁화 고딕"/>
+                  <a:ea typeface="무궁화 고딕"/>
+                  <a:cs typeface="무궁화 고딕"/>
+                  <a:sym typeface="무궁화 고딕"/>
                 </a:rPr>
                 <a:t>가장 많은 제시어를 맞춘 팀이 우승합니다.</a:t>
               </a:r>
@@ -4831,8 +4827,8 @@
           </p:nvSpPr>
           <p:spPr>
             <a:xfrm rot="0">
-              <a:off x="0" y="-171450"/>
-              <a:ext cx="11316164" cy="1171105"/>
+              <a:off x="0" y="-57150"/>
+              <a:ext cx="11316164" cy="1053029"/>
             </a:xfrm>
             <a:prstGeom prst="rect">
               <a:avLst/>
@@ -4854,10 +4850,10 @@
                   <a:solidFill>
                     <a:srgbClr val="FFFAEF"/>
                   </a:solidFill>
-                  <a:latin typeface="Jua"/>
-                  <a:ea typeface="Jua"/>
-                  <a:cs typeface="Jua"/>
-                  <a:sym typeface="Jua"/>
+                  <a:latin typeface="무궁화 고딕 Bold"/>
+                  <a:ea typeface="무궁화 고딕 Bold"/>
+                  <a:cs typeface="무궁화 고딕 Bold"/>
+                  <a:sym typeface="무궁화 고딕 Bold"/>
                 </a:rPr>
                 <a:t>STEP 3.</a:t>
               </a:r>
@@ -4874,9 +4870,9 @@
         <p:grpSpPr>
           <a:xfrm rot="0">
             <a:off x="4621704" y="4189067"/>
-            <a:ext cx="8612946" cy="2570047"/>
+            <a:ext cx="8612946" cy="2402261"/>
             <a:chOff x="0" y="0"/>
-            <a:chExt cx="11483928" cy="3426730"/>
+            <a:chExt cx="11483928" cy="3203015"/>
           </a:xfrm>
         </p:grpSpPr>
         <p:sp>
@@ -4887,8 +4883,8 @@
           </p:nvSpPr>
           <p:spPr>
             <a:xfrm rot="0">
-              <a:off x="0" y="1375218"/>
-              <a:ext cx="11483928" cy="2051512"/>
+              <a:off x="0" y="1382681"/>
+              <a:ext cx="11483928" cy="1820333"/>
             </a:xfrm>
             <a:prstGeom prst="rect">
               <a:avLst/>
@@ -4902,18 +4898,18 @@
             <a:p>
               <a:pPr algn="l">
                 <a:lnSpc>
-                  <a:spcPts val="6275"/>
+                  <a:spcPts val="5599"/>
                 </a:lnSpc>
               </a:pPr>
               <a:r>
-                <a:rPr lang="en-US" sz="4482">
+                <a:rPr lang="en-US" sz="3999">
                   <a:solidFill>
                     <a:srgbClr val="FFFAEF"/>
                   </a:solidFill>
-                  <a:latin typeface="TDTD가온"/>
-                  <a:ea typeface="TDTD가온"/>
-                  <a:cs typeface="TDTD가온"/>
-                  <a:sym typeface="TDTD가온"/>
+                  <a:latin typeface="무궁화 고딕"/>
+                  <a:ea typeface="무궁화 고딕"/>
+                  <a:cs typeface="무궁화 고딕"/>
+                  <a:sym typeface="무궁화 고딕"/>
                 </a:rPr>
                 <a:t>말 없이 몸동작으로만 표현하세요.</a:t>
               </a:r>
@@ -4921,18 +4917,18 @@
             <a:p>
               <a:pPr algn="l">
                 <a:lnSpc>
-                  <a:spcPts val="6275"/>
+                  <a:spcPts val="5599"/>
                 </a:lnSpc>
               </a:pPr>
               <a:r>
-                <a:rPr lang="en-US" sz="4482">
+                <a:rPr lang="en-US" sz="3999">
                   <a:solidFill>
                     <a:srgbClr val="FFFAEF"/>
                   </a:solidFill>
-                  <a:latin typeface="TDTD가온"/>
-                  <a:ea typeface="TDTD가온"/>
-                  <a:cs typeface="TDTD가온"/>
-                  <a:sym typeface="TDTD가온"/>
+                  <a:latin typeface="무궁화 고딕"/>
+                  <a:ea typeface="무궁화 고딕"/>
+                  <a:cs typeface="무궁화 고딕"/>
+                  <a:sym typeface="무궁화 고딕"/>
                 </a:rPr>
                 <a:t>3분 안에 최대한 많은 제시어를 맞추세요!</a:t>
               </a:r>
@@ -4947,8 +4943,8 @@
           </p:nvSpPr>
           <p:spPr>
             <a:xfrm rot="0">
-              <a:off x="0" y="-171450"/>
-              <a:ext cx="7079955" cy="1169523"/>
+              <a:off x="0" y="-57150"/>
+              <a:ext cx="7079955" cy="1053161"/>
             </a:xfrm>
             <a:prstGeom prst="rect">
               <a:avLst/>
@@ -4970,10 +4966,10 @@
                   <a:solidFill>
                     <a:srgbClr val="FFFAEF"/>
                   </a:solidFill>
-                  <a:latin typeface="Jua"/>
-                  <a:ea typeface="Jua"/>
-                  <a:cs typeface="Jua"/>
-                  <a:sym typeface="Jua"/>
+                  <a:latin typeface="무궁화 고딕 Bold"/>
+                  <a:ea typeface="무궁화 고딕 Bold"/>
+                  <a:cs typeface="무궁화 고딕 Bold"/>
+                  <a:sym typeface="무궁화 고딕 Bold"/>
                 </a:rPr>
                 <a:t>STEP 2.</a:t>
               </a:r>
@@ -5021,8 +5017,8 @@
         </p:nvSpPr>
         <p:spPr>
           <a:xfrm rot="0">
-            <a:off x="3238925" y="4092795"/>
-            <a:ext cx="11810151" cy="2200275"/>
+            <a:off x="3238925" y="4378545"/>
+            <a:ext cx="11810151" cy="1914525"/>
           </a:xfrm>
           <a:prstGeom prst="rect">
             <a:avLst/>
@@ -5044,10 +5040,10 @@
                 <a:solidFill>
                   <a:srgbClr val="000000"/>
                 </a:solidFill>
-                <a:latin typeface="Jua"/>
-                <a:ea typeface="Jua"/>
-                <a:cs typeface="Jua"/>
-                <a:sym typeface="Jua"/>
+                <a:latin typeface="무궁화 고딕"/>
+                <a:ea typeface="무궁화 고딕"/>
+                <a:cs typeface="무궁화 고딕"/>
+                <a:sym typeface="무궁화 고딕"/>
               </a:rPr>
               <a:t>축구</a:t>
             </a:r>
@@ -5144,8 +5140,8 @@
         </p:nvSpPr>
         <p:spPr>
           <a:xfrm rot="0">
-            <a:off x="3238925" y="4092795"/>
-            <a:ext cx="11810151" cy="2200275"/>
+            <a:off x="3238925" y="4378545"/>
+            <a:ext cx="11810151" cy="1914525"/>
           </a:xfrm>
           <a:prstGeom prst="rect">
             <a:avLst/>
@@ -5167,10 +5163,10 @@
                 <a:solidFill>
                   <a:srgbClr val="000000"/>
                 </a:solidFill>
-                <a:latin typeface="Jua"/>
-                <a:ea typeface="Jua"/>
-                <a:cs typeface="Jua"/>
-                <a:sym typeface="Jua"/>
+                <a:latin typeface="무궁화 고딕"/>
+                <a:ea typeface="무궁화 고딕"/>
+                <a:cs typeface="무궁화 고딕"/>
+                <a:sym typeface="무궁화 고딕"/>
               </a:rPr>
               <a:t>좀비</a:t>
             </a:r>
@@ -5267,8 +5263,8 @@
         </p:nvSpPr>
         <p:spPr>
           <a:xfrm rot="0">
-            <a:off x="2133812" y="3895725"/>
-            <a:ext cx="14020375" cy="2200275"/>
+            <a:off x="2133812" y="4267200"/>
+            <a:ext cx="14020375" cy="1743075"/>
           </a:xfrm>
           <a:prstGeom prst="rect">
             <a:avLst/>
@@ -5282,18 +5278,18 @@
           <a:p>
             <a:pPr algn="ctr">
               <a:lnSpc>
-                <a:spcPts val="15000"/>
+                <a:spcPts val="13680"/>
               </a:lnSpc>
             </a:pPr>
             <a:r>
-              <a:rPr lang="en-US" sz="12500">
+              <a:rPr lang="en-US" sz="11400">
                 <a:solidFill>
                   <a:srgbClr val="000000"/>
                 </a:solidFill>
-                <a:latin typeface="Jua"/>
-                <a:ea typeface="Jua"/>
-                <a:cs typeface="Jua"/>
-                <a:sym typeface="Jua"/>
+                <a:latin typeface="무궁화 고딕"/>
+                <a:ea typeface="무궁화 고딕"/>
+                <a:cs typeface="무궁화 고딕"/>
+                <a:sym typeface="무궁화 고딕"/>
               </a:rPr>
               <a:t>매운 떡볶이 먹는 외국인</a:t>
             </a:r>
@@ -5390,8 +5386,8 @@
         </p:nvSpPr>
         <p:spPr>
           <a:xfrm rot="0">
-            <a:off x="3238925" y="4092795"/>
-            <a:ext cx="11810151" cy="2200275"/>
+            <a:off x="3238925" y="4378545"/>
+            <a:ext cx="11810151" cy="1914525"/>
           </a:xfrm>
           <a:prstGeom prst="rect">
             <a:avLst/>
@@ -5413,10 +5409,10 @@
                 <a:solidFill>
                   <a:srgbClr val="000000"/>
                 </a:solidFill>
-                <a:latin typeface="Jua"/>
-                <a:ea typeface="Jua"/>
-                <a:cs typeface="Jua"/>
-                <a:sym typeface="Jua"/>
+                <a:latin typeface="무궁화 고딕"/>
+                <a:ea typeface="무궁화 고딕"/>
+                <a:cs typeface="무궁화 고딕"/>
+                <a:sym typeface="무궁화 고딕"/>
               </a:rPr>
               <a:t>기린</a:t>
             </a:r>
@@ -5513,8 +5509,8 @@
         </p:nvSpPr>
         <p:spPr>
           <a:xfrm rot="0">
-            <a:off x="1965583" y="2943225"/>
-            <a:ext cx="14356835" cy="4105275"/>
+            <a:off x="1965583" y="3228975"/>
+            <a:ext cx="14356835" cy="3819525"/>
           </a:xfrm>
           <a:prstGeom prst="rect">
             <a:avLst/>
@@ -5536,10 +5532,10 @@
                 <a:solidFill>
                   <a:srgbClr val="000000"/>
                 </a:solidFill>
-                <a:latin typeface="Jua"/>
-                <a:ea typeface="Jua"/>
-                <a:cs typeface="Jua"/>
-                <a:sym typeface="Jua"/>
+                <a:latin typeface="무궁화 고딕"/>
+                <a:ea typeface="무궁화 고딕"/>
+                <a:cs typeface="무궁화 고딕"/>
+                <a:sym typeface="무궁화 고딕"/>
               </a:rPr>
               <a:t>엘리베이터에 갇힌</a:t>
             </a:r>
@@ -5555,10 +5551,10 @@
                 <a:solidFill>
                   <a:srgbClr val="000000"/>
                 </a:solidFill>
-                <a:latin typeface="Jua"/>
-                <a:ea typeface="Jua"/>
-                <a:cs typeface="Jua"/>
-                <a:sym typeface="Jua"/>
+                <a:latin typeface="무궁화 고딕"/>
+                <a:ea typeface="무궁화 고딕"/>
+                <a:cs typeface="무궁화 고딕"/>
+                <a:sym typeface="무궁화 고딕"/>
               </a:rPr>
               <a:t>산타클로스</a:t>
             </a:r>
@@ -5655,8 +5651,8 @@
         </p:nvSpPr>
         <p:spPr>
           <a:xfrm rot="0">
-            <a:off x="3238925" y="4092795"/>
-            <a:ext cx="11810151" cy="2200275"/>
+            <a:off x="3238925" y="4378545"/>
+            <a:ext cx="11810151" cy="1914525"/>
           </a:xfrm>
           <a:prstGeom prst="rect">
             <a:avLst/>
@@ -5678,10 +5674,10 @@
                 <a:solidFill>
                   <a:srgbClr val="000000"/>
                 </a:solidFill>
-                <a:latin typeface="Jua"/>
-                <a:ea typeface="Jua"/>
-                <a:cs typeface="Jua"/>
-                <a:sym typeface="Jua"/>
+                <a:latin typeface="무궁화 고딕"/>
+                <a:ea typeface="무궁화 고딕"/>
+                <a:cs typeface="무궁화 고딕"/>
+                <a:sym typeface="무궁화 고딕"/>
               </a:rPr>
               <a:t>거북이</a:t>
             </a:r>
@@ -5778,8 +5774,8 @@
         </p:nvSpPr>
         <p:spPr>
           <a:xfrm rot="0">
-            <a:off x="3238925" y="4092795"/>
-            <a:ext cx="11810151" cy="2200275"/>
+            <a:off x="3238925" y="4378545"/>
+            <a:ext cx="11810151" cy="1914525"/>
           </a:xfrm>
           <a:prstGeom prst="rect">
             <a:avLst/>
@@ -5801,10 +5797,10 @@
                 <a:solidFill>
                   <a:srgbClr val="000000"/>
                 </a:solidFill>
-                <a:latin typeface="Jua"/>
-                <a:ea typeface="Jua"/>
-                <a:cs typeface="Jua"/>
-                <a:sym typeface="Jua"/>
+                <a:latin typeface="무궁화 고딕"/>
+                <a:ea typeface="무궁화 고딕"/>
+                <a:cs typeface="무궁화 고딕"/>
+                <a:sym typeface="무궁화 고딕"/>
               </a:rPr>
               <a:t>림보</a:t>
             </a:r>
@@ -5901,8 +5897,8 @@
         </p:nvSpPr>
         <p:spPr>
           <a:xfrm rot="0">
-            <a:off x="1323898" y="3895725"/>
-            <a:ext cx="15640203" cy="2200275"/>
+            <a:off x="1323898" y="4252913"/>
+            <a:ext cx="15640203" cy="1771650"/>
           </a:xfrm>
           <a:prstGeom prst="rect">
             <a:avLst/>
@@ -5916,18 +5912,18 @@
           <a:p>
             <a:pPr algn="ctr">
               <a:lnSpc>
-                <a:spcPts val="15000"/>
+                <a:spcPts val="13920"/>
               </a:lnSpc>
             </a:pPr>
             <a:r>
-              <a:rPr lang="en-US" sz="12500">
+              <a:rPr lang="en-US" sz="11600">
                 <a:solidFill>
                   <a:srgbClr val="000000"/>
                 </a:solidFill>
-                <a:latin typeface="Jua"/>
-                <a:ea typeface="Jua"/>
-                <a:cs typeface="Jua"/>
-                <a:sym typeface="Jua"/>
+                <a:latin typeface="무궁화 고딕"/>
+                <a:ea typeface="무궁화 고딕"/>
+                <a:cs typeface="무궁화 고딕"/>
+                <a:sym typeface="무궁화 고딕"/>
               </a:rPr>
               <a:t>미용실에서 머리 망한 사람</a:t>
             </a:r>
@@ -6024,8 +6020,8 @@
         </p:nvSpPr>
         <p:spPr>
           <a:xfrm rot="0">
-            <a:off x="3238925" y="4092795"/>
-            <a:ext cx="11810151" cy="2200275"/>
+            <a:off x="3238925" y="4378545"/>
+            <a:ext cx="11810151" cy="1914525"/>
           </a:xfrm>
           <a:prstGeom prst="rect">
             <a:avLst/>
@@ -6047,10 +6043,10 @@
                 <a:solidFill>
                   <a:srgbClr val="000000"/>
                 </a:solidFill>
-                <a:latin typeface="Jua"/>
-                <a:ea typeface="Jua"/>
-                <a:cs typeface="Jua"/>
-                <a:sym typeface="Jua"/>
+                <a:latin typeface="무궁화 고딕"/>
+                <a:ea typeface="무궁화 고딕"/>
+                <a:cs typeface="무궁화 고딕"/>
+                <a:sym typeface="무궁화 고딕"/>
               </a:rPr>
               <a:t>스키</a:t>
             </a:r>
@@ -6147,8 +6143,8 @@
         </p:nvSpPr>
         <p:spPr>
           <a:xfrm rot="0">
-            <a:off x="3238925" y="3140295"/>
-            <a:ext cx="11810151" cy="4105275"/>
+            <a:off x="3238925" y="3426045"/>
+            <a:ext cx="11810151" cy="3819525"/>
           </a:xfrm>
           <a:prstGeom prst="rect">
             <a:avLst/>
@@ -6170,10 +6166,10 @@
                 <a:solidFill>
                   <a:srgbClr val="000000"/>
                 </a:solidFill>
-                <a:latin typeface="Jua"/>
-                <a:ea typeface="Jua"/>
-                <a:cs typeface="Jua"/>
-                <a:sym typeface="Jua"/>
+                <a:latin typeface="무궁화 고딕"/>
+                <a:ea typeface="무궁화 고딕"/>
+                <a:cs typeface="무궁화 고딕"/>
+                <a:sym typeface="무궁화 고딕"/>
               </a:rPr>
               <a:t>롤러코스터에서</a:t>
             </a:r>
@@ -6189,10 +6185,10 @@
                 <a:solidFill>
                   <a:srgbClr val="000000"/>
                 </a:solidFill>
-                <a:latin typeface="Jua"/>
-                <a:ea typeface="Jua"/>
-                <a:cs typeface="Jua"/>
-                <a:sym typeface="Jua"/>
+                <a:latin typeface="무궁화 고딕"/>
+                <a:ea typeface="무궁화 고딕"/>
+                <a:cs typeface="무궁화 고딕"/>
+                <a:sym typeface="무궁화 고딕"/>
               </a:rPr>
               <a:t>핸드폰 떨어뜨림</a:t>
             </a:r>
@@ -6289,8 +6285,8 @@
         </p:nvSpPr>
         <p:spPr>
           <a:xfrm rot="0">
-            <a:off x="3238925" y="4092795"/>
-            <a:ext cx="11810151" cy="2200275"/>
+            <a:off x="3238925" y="4378545"/>
+            <a:ext cx="11810151" cy="1914525"/>
           </a:xfrm>
           <a:prstGeom prst="rect">
             <a:avLst/>
@@ -6312,10 +6308,10 @@
                 <a:solidFill>
                   <a:srgbClr val="000000"/>
                 </a:solidFill>
-                <a:latin typeface="Jua"/>
-                <a:ea typeface="Jua"/>
-                <a:cs typeface="Jua"/>
-                <a:sym typeface="Jua"/>
+                <a:latin typeface="무궁화 고딕"/>
+                <a:ea typeface="무궁화 고딕"/>
+                <a:cs typeface="무궁화 고딕"/>
+                <a:sym typeface="무궁화 고딕"/>
               </a:rPr>
               <a:t>팀을 나눠주세요!</a:t>
             </a:r>
@@ -6412,8 +6408,8 @@
         </p:nvSpPr>
         <p:spPr>
           <a:xfrm rot="0">
-            <a:off x="3238925" y="4092795"/>
-            <a:ext cx="11810151" cy="2200275"/>
+            <a:off x="3238925" y="4378545"/>
+            <a:ext cx="11810151" cy="1914525"/>
           </a:xfrm>
           <a:prstGeom prst="rect">
             <a:avLst/>
@@ -6435,10 +6431,10 @@
                 <a:solidFill>
                   <a:srgbClr val="000000"/>
                 </a:solidFill>
-                <a:latin typeface="Jua"/>
-                <a:ea typeface="Jua"/>
-                <a:cs typeface="Jua"/>
-                <a:sym typeface="Jua"/>
+                <a:latin typeface="무궁화 고딕"/>
+                <a:ea typeface="무궁화 고딕"/>
+                <a:cs typeface="무궁화 고딕"/>
+                <a:sym typeface="무궁화 고딕"/>
               </a:rPr>
               <a:t>화장실 급한 사람</a:t>
             </a:r>
@@ -6535,8 +6531,8 @@
         </p:nvSpPr>
         <p:spPr>
           <a:xfrm rot="0">
-            <a:off x="3238925" y="3140295"/>
-            <a:ext cx="11810151" cy="4105275"/>
+            <a:off x="3238925" y="3549870"/>
+            <a:ext cx="11810151" cy="3571875"/>
           </a:xfrm>
           <a:prstGeom prst="rect">
             <a:avLst/>
@@ -6550,18 +6546,18 @@
           <a:p>
             <a:pPr algn="ctr">
               <a:lnSpc>
-                <a:spcPts val="15000"/>
+                <a:spcPts val="14040"/>
               </a:lnSpc>
             </a:pPr>
             <a:r>
-              <a:rPr lang="en-US" sz="12500">
+              <a:rPr lang="en-US" sz="11700">
                 <a:solidFill>
                   <a:srgbClr val="000000"/>
                 </a:solidFill>
-                <a:latin typeface="Jua"/>
-                <a:ea typeface="Jua"/>
-                <a:cs typeface="Jua"/>
-                <a:sym typeface="Jua"/>
+                <a:latin typeface="무궁화 고딕"/>
+                <a:ea typeface="무궁화 고딕"/>
+                <a:cs typeface="무궁화 고딕"/>
+                <a:sym typeface="무궁화 고딕"/>
               </a:rPr>
               <a:t>다이어트 중</a:t>
             </a:r>
@@ -6569,18 +6565,18 @@
           <a:p>
             <a:pPr algn="ctr">
               <a:lnSpc>
-                <a:spcPts val="15000"/>
+                <a:spcPts val="14040"/>
               </a:lnSpc>
             </a:pPr>
             <a:r>
-              <a:rPr lang="en-US" sz="12500">
+              <a:rPr lang="en-US" sz="11700">
                 <a:solidFill>
                   <a:srgbClr val="000000"/>
                 </a:solidFill>
-                <a:latin typeface="Jua"/>
-                <a:ea typeface="Jua"/>
-                <a:cs typeface="Jua"/>
-                <a:sym typeface="Jua"/>
+                <a:latin typeface="무궁화 고딕"/>
+                <a:ea typeface="무궁화 고딕"/>
+                <a:cs typeface="무궁화 고딕"/>
+                <a:sym typeface="무궁화 고딕"/>
               </a:rPr>
               <a:t>치킨 냄새 맡은 사람</a:t>
             </a:r>
@@ -6677,8 +6673,8 @@
         </p:nvSpPr>
         <p:spPr>
           <a:xfrm rot="0">
-            <a:off x="3238925" y="4092795"/>
-            <a:ext cx="11810151" cy="2200275"/>
+            <a:off x="3238925" y="4411883"/>
+            <a:ext cx="11810151" cy="1847850"/>
           </a:xfrm>
           <a:prstGeom prst="rect">
             <a:avLst/>
@@ -6692,18 +6688,18 @@
           <a:p>
             <a:pPr algn="ctr">
               <a:lnSpc>
-                <a:spcPts val="15000"/>
+                <a:spcPts val="14520"/>
               </a:lnSpc>
             </a:pPr>
             <a:r>
-              <a:rPr lang="en-US" sz="12500">
+              <a:rPr lang="en-US" sz="12100">
                 <a:solidFill>
                   <a:srgbClr val="000000"/>
                 </a:solidFill>
-                <a:latin typeface="Jua"/>
-                <a:ea typeface="Jua"/>
-                <a:cs typeface="Jua"/>
-                <a:sym typeface="Jua"/>
+                <a:latin typeface="무궁화 고딕"/>
+                <a:ea typeface="무궁화 고딕"/>
+                <a:cs typeface="무궁화 고딕"/>
+                <a:sym typeface="무궁화 고딕"/>
               </a:rPr>
               <a:t>자장가 부르는 군인</a:t>
             </a:r>
@@ -6825,8 +6821,8 @@
         </p:nvSpPr>
         <p:spPr>
           <a:xfrm rot="0">
-            <a:off x="4421807" y="3895725"/>
-            <a:ext cx="9444385" cy="2200275"/>
+            <a:off x="4421807" y="4181475"/>
+            <a:ext cx="9444385" cy="1914525"/>
           </a:xfrm>
           <a:prstGeom prst="rect">
             <a:avLst/>
@@ -6848,10 +6844,10 @@
                 <a:solidFill>
                   <a:srgbClr val="000000"/>
                 </a:solidFill>
-                <a:latin typeface="Jua"/>
-                <a:ea typeface="Jua"/>
-                <a:cs typeface="Jua"/>
-                <a:sym typeface="Jua"/>
+                <a:latin typeface="무궁화 고딕"/>
+                <a:ea typeface="무궁화 고딕"/>
+                <a:cs typeface="무궁화 고딕"/>
+                <a:sym typeface="무궁화 고딕"/>
               </a:rPr>
               <a:t>감사합니다!</a:t>
             </a:r>
@@ -6998,8 +6994,8 @@
         </p:nvSpPr>
         <p:spPr>
           <a:xfrm rot="0">
-            <a:off x="1028700" y="3892867"/>
-            <a:ext cx="15555091" cy="2200275"/>
+            <a:off x="1028700" y="4178617"/>
+            <a:ext cx="15555091" cy="1914525"/>
           </a:xfrm>
           <a:prstGeom prst="rect">
             <a:avLst/>
@@ -7021,10 +7017,10 @@
                 <a:solidFill>
                   <a:srgbClr val="FFFAEF"/>
                 </a:solidFill>
-                <a:latin typeface="Jua"/>
-                <a:ea typeface="Jua"/>
-                <a:cs typeface="Jua"/>
-                <a:sym typeface="Jua"/>
+                <a:latin typeface="무궁화 고딕"/>
+                <a:ea typeface="무궁화 고딕"/>
+                <a:cs typeface="무궁화 고딕"/>
+                <a:sym typeface="무궁화 고딕"/>
               </a:rPr>
               <a:t>몸으로 말해요</a:t>
             </a:r>
@@ -7039,8 +7035,8 @@
         </p:nvSpPr>
         <p:spPr>
           <a:xfrm rot="0">
-            <a:off x="15264803" y="9812655"/>
-            <a:ext cx="2637975" cy="474345"/>
+            <a:off x="13460066" y="9822180"/>
+            <a:ext cx="4442712" cy="464820"/>
           </a:xfrm>
           <a:prstGeom prst="rect">
             <a:avLst/>
@@ -7065,10 +7061,10 @@
                 <a:solidFill>
                   <a:srgbClr val="FFFFFF"/>
                 </a:solidFill>
-                <a:latin typeface="TDTD갬성명조"/>
-                <a:ea typeface="TDTD갬성명조"/>
-                <a:cs typeface="TDTD갬성명조"/>
-                <a:sym typeface="TDTD갬성명조"/>
+                <a:latin typeface="무궁화 고딕"/>
+                <a:ea typeface="무궁화 고딕"/>
+                <a:cs typeface="무궁화 고딕"/>
+                <a:sym typeface="무궁화 고딕"/>
               </a:rPr>
               <a:t>ⓒ 2026. Sunday Play</a:t>
             </a:r>
@@ -7115,8 +7111,8 @@
         </p:nvSpPr>
         <p:spPr>
           <a:xfrm rot="0">
-            <a:off x="3238925" y="4092795"/>
-            <a:ext cx="11810151" cy="2200275"/>
+            <a:off x="3238925" y="4378545"/>
+            <a:ext cx="11810151" cy="1914525"/>
           </a:xfrm>
           <a:prstGeom prst="rect">
             <a:avLst/>
@@ -7138,10 +7134,10 @@
                 <a:solidFill>
                   <a:srgbClr val="000000"/>
                 </a:solidFill>
-                <a:latin typeface="Jua"/>
-                <a:ea typeface="Jua"/>
-                <a:cs typeface="Jua"/>
-                <a:sym typeface="Jua"/>
+                <a:latin typeface="무궁화 고딕"/>
+                <a:ea typeface="무궁화 고딕"/>
+                <a:cs typeface="무궁화 고딕"/>
+                <a:sym typeface="무궁화 고딕"/>
               </a:rPr>
               <a:t>원숭이</a:t>
             </a:r>
@@ -7238,8 +7234,8 @@
         </p:nvSpPr>
         <p:spPr>
           <a:xfrm rot="0">
-            <a:off x="3238925" y="4092795"/>
-            <a:ext cx="11810151" cy="2200275"/>
+            <a:off x="3238925" y="4378545"/>
+            <a:ext cx="11810151" cy="1914525"/>
           </a:xfrm>
           <a:prstGeom prst="rect">
             <a:avLst/>
@@ -7261,10 +7257,10 @@
                 <a:solidFill>
                   <a:srgbClr val="000000"/>
                 </a:solidFill>
-                <a:latin typeface="Jua"/>
-                <a:ea typeface="Jua"/>
-                <a:cs typeface="Jua"/>
-                <a:sym typeface="Jua"/>
+                <a:latin typeface="무궁화 고딕"/>
+                <a:ea typeface="무궁화 고딕"/>
+                <a:cs typeface="무궁화 고딕"/>
+                <a:sym typeface="무궁화 고딕"/>
               </a:rPr>
               <a:t>펭귄</a:t>
             </a:r>
@@ -7361,8 +7357,8 @@
         </p:nvSpPr>
         <p:spPr>
           <a:xfrm rot="0">
-            <a:off x="3238925" y="3140295"/>
-            <a:ext cx="11810151" cy="4105275"/>
+            <a:off x="3238925" y="3426045"/>
+            <a:ext cx="11810151" cy="3819525"/>
           </a:xfrm>
           <a:prstGeom prst="rect">
             <a:avLst/>
@@ -7384,10 +7380,10 @@
                 <a:solidFill>
                   <a:srgbClr val="000000"/>
                 </a:solidFill>
-                <a:latin typeface="Jua"/>
-                <a:ea typeface="Jua"/>
-                <a:cs typeface="Jua"/>
-                <a:sym typeface="Jua"/>
+                <a:latin typeface="무궁화 고딕"/>
+                <a:ea typeface="무궁화 고딕"/>
+                <a:cs typeface="무궁화 고딕"/>
+                <a:sym typeface="무궁화 고딕"/>
               </a:rPr>
               <a:t>번지점프</a:t>
             </a:r>
@@ -7403,10 +7399,10 @@
                 <a:solidFill>
                   <a:srgbClr val="000000"/>
                 </a:solidFill>
-                <a:latin typeface="Jua"/>
-                <a:ea typeface="Jua"/>
-                <a:cs typeface="Jua"/>
-                <a:sym typeface="Jua"/>
+                <a:latin typeface="무궁화 고딕"/>
+                <a:ea typeface="무궁화 고딕"/>
+                <a:cs typeface="무궁화 고딕"/>
+                <a:sym typeface="무궁화 고딕"/>
               </a:rPr>
               <a:t>무서워하는 슈퍼맨</a:t>
             </a:r>
@@ -7503,8 +7499,8 @@
         </p:nvSpPr>
         <p:spPr>
           <a:xfrm rot="0">
-            <a:off x="3238925" y="4092795"/>
-            <a:ext cx="11810151" cy="2200275"/>
+            <a:off x="3238925" y="4378545"/>
+            <a:ext cx="11810151" cy="1914525"/>
           </a:xfrm>
           <a:prstGeom prst="rect">
             <a:avLst/>
@@ -7526,10 +7522,10 @@
                 <a:solidFill>
                   <a:srgbClr val="000000"/>
                 </a:solidFill>
-                <a:latin typeface="Jua"/>
-                <a:ea typeface="Jua"/>
-                <a:cs typeface="Jua"/>
-                <a:sym typeface="Jua"/>
+                <a:latin typeface="무궁화 고딕"/>
+                <a:ea typeface="무궁화 고딕"/>
+                <a:cs typeface="무궁화 고딕"/>
+                <a:sym typeface="무궁화 고딕"/>
               </a:rPr>
               <a:t>세탁기</a:t>
             </a:r>
@@ -7626,8 +7622,8 @@
         </p:nvSpPr>
         <p:spPr>
           <a:xfrm rot="0">
-            <a:off x="3238925" y="4092795"/>
-            <a:ext cx="11810151" cy="2200275"/>
+            <a:off x="3238925" y="4378545"/>
+            <a:ext cx="11810151" cy="1914525"/>
           </a:xfrm>
           <a:prstGeom prst="rect">
             <a:avLst/>
@@ -7649,10 +7645,10 @@
                 <a:solidFill>
                   <a:srgbClr val="000000"/>
                 </a:solidFill>
-                <a:latin typeface="Jua"/>
-                <a:ea typeface="Jua"/>
-                <a:cs typeface="Jua"/>
-                <a:sym typeface="Jua"/>
+                <a:latin typeface="무궁화 고딕"/>
+                <a:ea typeface="무궁화 고딕"/>
+                <a:cs typeface="무궁화 고딕"/>
+                <a:sym typeface="무궁화 고딕"/>
               </a:rPr>
               <a:t>요리하는 소방관</a:t>
             </a:r>

</xml_diff>